<commit_message>
Name the four Riftbrawl teams in the proposal deck
Disguised, The Secret Sauce, Ascension and Challenger TCG now appear on
the title ring, the format slide, the Singapore recap (team chips), and
the closing checklist.

Co-Authored-By: Claude Fable 5.1 <noreply@anthropic.com>
Claude-Session: https://claude.ai/code/session_01X5rZmKPc5GMpr9Lxtrr5ir
</commit_message>
<xml_diff>
--- a/decks/riftbrawl/Riftbrawl_Proposal.pptx
+++ b/decks/riftbrawl/Riftbrawl_Proposal.pptx
@@ -685,7 +685,7 @@
           <a:p>
             <a:r>
               <a:rPr lang="en-US" dirty="0"/>
-              <a:t>Riftbrawl Singapore was a mini tournament for top teams attending RQ Singapore. Four teams (DSG, TSS, ASC, CTCG), streamed with co-streams; VODs uploaded roughly five days ago. Per-video view counts should be pulled from YouTube Studio before sending.</a:t>
+              <a:t>Riftbrawl Singapore was a mini tournament for top teams attending RQ Singapore. Four teams (Disguised, The Secret Sauce, Ascension, Challenger TCG), streamed with co-streams; VODs uploaded roughly five days ago. Per-video view counts should be pulled from YouTube Studio before sending.</a:t>
             </a:r>
             <a:endParaRPr lang="en-US" dirty="0"/>
           </a:p>
@@ -1680,8 +1680,8 @@
         </p:nvSpPr>
         <p:spPr>
           <a:xfrm>
-            <a:off x="8938260" y="1485900"/>
-            <a:ext cx="1051560" cy="1051560"/>
+            <a:off x="9011412" y="1485900"/>
+            <a:ext cx="905256" cy="1051560"/>
           </a:xfrm>
           <a:prstGeom prst="rect">
             <a:avLst/>
@@ -1697,24 +1697,24 @@
               <a:buNone/>
             </a:pPr>
             <a:r>
-              <a:rPr lang="en-US" sz="900" dirty="0">
-                <a:solidFill>
-                  <a:srgbClr val="C8AA6E"/>
-                </a:solidFill>
-                <a:latin typeface="Calibri" pitchFamily="34" charset="0"/>
-                <a:ea typeface="Calibri" pitchFamily="34" charset="-122"/>
-                <a:cs typeface="Calibri" pitchFamily="34" charset="-120"/>
-              </a:rPr>
-              <a:t>TEAM A</a:t>
-            </a:r>
-            <a:endParaRPr lang="en-US" sz="900" dirty="0"/>
+              <a:rPr lang="en-US" sz="1300" b="1" dirty="0">
+                <a:solidFill>
+                  <a:srgbClr val="F0C96A"/>
+                </a:solidFill>
+                <a:latin typeface="Calibri" pitchFamily="34" charset="0"/>
+                <a:ea typeface="Calibri" pitchFamily="34" charset="-122"/>
+                <a:cs typeface="Calibri" pitchFamily="34" charset="-120"/>
+              </a:rPr>
+              <a:t>DSG</a:t>
+            </a:r>
+            <a:endParaRPr lang="en-US" sz="1300" dirty="0"/>
           </a:p>
           <a:p>
             <a:pPr algn="ctr" indent="0" marL="0">
               <a:buNone/>
             </a:pPr>
             <a:r>
-              <a:rPr lang="en-US" sz="1050" b="1" dirty="0">
+              <a:rPr lang="en-US" sz="750" dirty="0">
                 <a:solidFill>
                   <a:srgbClr val="F0E6D2"/>
                 </a:solidFill>
@@ -1722,9 +1722,9 @@
                 <a:ea typeface="Calibri" pitchFamily="34" charset="-122"/>
                 <a:cs typeface="Calibri" pitchFamily="34" charset="-120"/>
               </a:rPr>
-              <a:t>3 players</a:t>
-            </a:r>
-            <a:endParaRPr lang="en-US" sz="900" dirty="0"/>
+              <a:t>Disguised</a:t>
+            </a:r>
+            <a:endParaRPr lang="en-US" sz="1300" dirty="0"/>
           </a:p>
         </p:txBody>
       </p:sp>
@@ -1761,8 +1761,8 @@
         </p:nvSpPr>
         <p:spPr>
           <a:xfrm>
-            <a:off x="10355580" y="2903220"/>
-            <a:ext cx="1051560" cy="1051560"/>
+            <a:off x="10428732" y="2903220"/>
+            <a:ext cx="905256" cy="1051560"/>
           </a:xfrm>
           <a:prstGeom prst="rect">
             <a:avLst/>
@@ -1778,24 +1778,24 @@
               <a:buNone/>
             </a:pPr>
             <a:r>
-              <a:rPr lang="en-US" sz="900" dirty="0">
-                <a:solidFill>
-                  <a:srgbClr val="C8AA6E"/>
-                </a:solidFill>
-                <a:latin typeface="Calibri" pitchFamily="34" charset="0"/>
-                <a:ea typeface="Calibri" pitchFamily="34" charset="-122"/>
-                <a:cs typeface="Calibri" pitchFamily="34" charset="-120"/>
-              </a:rPr>
-              <a:t>TEAM B</a:t>
-            </a:r>
-            <a:endParaRPr lang="en-US" sz="900" dirty="0"/>
+              <a:rPr lang="en-US" sz="1300" b="1" dirty="0">
+                <a:solidFill>
+                  <a:srgbClr val="F0C96A"/>
+                </a:solidFill>
+                <a:latin typeface="Calibri" pitchFamily="34" charset="0"/>
+                <a:ea typeface="Calibri" pitchFamily="34" charset="-122"/>
+                <a:cs typeface="Calibri" pitchFamily="34" charset="-120"/>
+              </a:rPr>
+              <a:t>TSS</a:t>
+            </a:r>
+            <a:endParaRPr lang="en-US" sz="1300" dirty="0"/>
           </a:p>
           <a:p>
             <a:pPr algn="ctr" indent="0" marL="0">
               <a:buNone/>
             </a:pPr>
             <a:r>
-              <a:rPr lang="en-US" sz="1050" b="1" dirty="0">
+              <a:rPr lang="en-US" sz="750" dirty="0">
                 <a:solidFill>
                   <a:srgbClr val="F0E6D2"/>
                 </a:solidFill>
@@ -1803,9 +1803,9 @@
                 <a:ea typeface="Calibri" pitchFamily="34" charset="-122"/>
                 <a:cs typeface="Calibri" pitchFamily="34" charset="-120"/>
               </a:rPr>
-              <a:t>3 players</a:t>
-            </a:r>
-            <a:endParaRPr lang="en-US" sz="900" dirty="0"/>
+              <a:t>The Secret Sauce</a:t>
+            </a:r>
+            <a:endParaRPr lang="en-US" sz="1300" dirty="0"/>
           </a:p>
         </p:txBody>
       </p:sp>
@@ -1842,8 +1842,8 @@
         </p:nvSpPr>
         <p:spPr>
           <a:xfrm>
-            <a:off x="8938260" y="4320540"/>
-            <a:ext cx="1051560" cy="1051560"/>
+            <a:off x="9011412" y="4320540"/>
+            <a:ext cx="905256" cy="1051560"/>
           </a:xfrm>
           <a:prstGeom prst="rect">
             <a:avLst/>
@@ -1859,24 +1859,24 @@
               <a:buNone/>
             </a:pPr>
             <a:r>
-              <a:rPr lang="en-US" sz="900" dirty="0">
-                <a:solidFill>
-                  <a:srgbClr val="C8AA6E"/>
-                </a:solidFill>
-                <a:latin typeface="Calibri" pitchFamily="34" charset="0"/>
-                <a:ea typeface="Calibri" pitchFamily="34" charset="-122"/>
-                <a:cs typeface="Calibri" pitchFamily="34" charset="-120"/>
-              </a:rPr>
-              <a:t>TEAM C</a:t>
-            </a:r>
-            <a:endParaRPr lang="en-US" sz="900" dirty="0"/>
+              <a:rPr lang="en-US" sz="1300" b="1" dirty="0">
+                <a:solidFill>
+                  <a:srgbClr val="F0C96A"/>
+                </a:solidFill>
+                <a:latin typeface="Calibri" pitchFamily="34" charset="0"/>
+                <a:ea typeface="Calibri" pitchFamily="34" charset="-122"/>
+                <a:cs typeface="Calibri" pitchFamily="34" charset="-120"/>
+              </a:rPr>
+              <a:t>ASC</a:t>
+            </a:r>
+            <a:endParaRPr lang="en-US" sz="1300" dirty="0"/>
           </a:p>
           <a:p>
             <a:pPr algn="ctr" indent="0" marL="0">
               <a:buNone/>
             </a:pPr>
             <a:r>
-              <a:rPr lang="en-US" sz="1050" b="1" dirty="0">
+              <a:rPr lang="en-US" sz="750" dirty="0">
                 <a:solidFill>
                   <a:srgbClr val="F0E6D2"/>
                 </a:solidFill>
@@ -1884,9 +1884,9 @@
                 <a:ea typeface="Calibri" pitchFamily="34" charset="-122"/>
                 <a:cs typeface="Calibri" pitchFamily="34" charset="-120"/>
               </a:rPr>
-              <a:t>3 players</a:t>
-            </a:r>
-            <a:endParaRPr lang="en-US" sz="900" dirty="0"/>
+              <a:t>Ascension</a:t>
+            </a:r>
+            <a:endParaRPr lang="en-US" sz="1300" dirty="0"/>
           </a:p>
         </p:txBody>
       </p:sp>
@@ -1923,8 +1923,8 @@
         </p:nvSpPr>
         <p:spPr>
           <a:xfrm>
-            <a:off x="7520940" y="2903220"/>
-            <a:ext cx="1051560" cy="1051560"/>
+            <a:off x="7594092" y="2903220"/>
+            <a:ext cx="905256" cy="1051560"/>
           </a:xfrm>
           <a:prstGeom prst="rect">
             <a:avLst/>
@@ -1940,24 +1940,24 @@
               <a:buNone/>
             </a:pPr>
             <a:r>
-              <a:rPr lang="en-US" sz="900" dirty="0">
-                <a:solidFill>
-                  <a:srgbClr val="C8AA6E"/>
-                </a:solidFill>
-                <a:latin typeface="Calibri" pitchFamily="34" charset="0"/>
-                <a:ea typeface="Calibri" pitchFamily="34" charset="-122"/>
-                <a:cs typeface="Calibri" pitchFamily="34" charset="-120"/>
-              </a:rPr>
-              <a:t>TEAM D</a:t>
-            </a:r>
-            <a:endParaRPr lang="en-US" sz="900" dirty="0"/>
+              <a:rPr lang="en-US" sz="1300" b="1" dirty="0">
+                <a:solidFill>
+                  <a:srgbClr val="F0C96A"/>
+                </a:solidFill>
+                <a:latin typeface="Calibri" pitchFamily="34" charset="0"/>
+                <a:ea typeface="Calibri" pitchFamily="34" charset="-122"/>
+                <a:cs typeface="Calibri" pitchFamily="34" charset="-120"/>
+              </a:rPr>
+              <a:t>CTCG</a:t>
+            </a:r>
+            <a:endParaRPr lang="en-US" sz="1300" dirty="0"/>
           </a:p>
           <a:p>
             <a:pPr algn="ctr" indent="0" marL="0">
               <a:buNone/>
             </a:pPr>
             <a:r>
-              <a:rPr lang="en-US" sz="1050" b="1" dirty="0">
+              <a:rPr lang="en-US" sz="750" dirty="0">
                 <a:solidFill>
                   <a:srgbClr val="F0E6D2"/>
                 </a:solidFill>
@@ -1965,9 +1965,9 @@
                 <a:ea typeface="Calibri" pitchFamily="34" charset="-122"/>
                 <a:cs typeface="Calibri" pitchFamily="34" charset="-120"/>
               </a:rPr>
-              <a:t>3 players</a:t>
-            </a:r>
-            <a:endParaRPr lang="en-US" sz="900" dirty="0"/>
+              <a:t>Challenger TCG</a:t>
+            </a:r>
+            <a:endParaRPr lang="en-US" sz="1300" dirty="0"/>
           </a:p>
         </p:txBody>
       </p:sp>
@@ -2397,7 +2397,7 @@
                 <a:ea typeface="Calibri" pitchFamily="34" charset="-122"/>
                 <a:cs typeface="Calibri" pitchFamily="34" charset="-120"/>
               </a:rPr>
-              <a:t>12 invited players in a 3v3v3v3 team brawl. Room to flex to 16 with an alternate per team.</a:t>
+              <a:t>Disguised, The Secret Sauce, Ascension and Challenger TCG in a 3v3v3v3 team brawl. Flexes to 16 with an alternate per team.</a:t>
             </a:r>
             <a:endParaRPr lang="en-US" sz="1250" dirty="0"/>
           </a:p>
@@ -3482,7 +3482,7 @@
         </p:nvSpPr>
         <p:spPr>
           <a:xfrm>
-            <a:off x="594360" y="1828800"/>
+            <a:off x="594360" y="1783080"/>
             <a:ext cx="2377440" cy="777240"/>
           </a:xfrm>
           <a:prstGeom prst="rect">
@@ -3521,7 +3521,7 @@
         </p:nvSpPr>
         <p:spPr>
           <a:xfrm>
-            <a:off x="594360" y="2651760"/>
+            <a:off x="594360" y="2606040"/>
             <a:ext cx="2377440" cy="502920"/>
           </a:xfrm>
           <a:prstGeom prst="rect">
@@ -3546,7 +3546,7 @@
                 <a:ea typeface="Calibri" pitchFamily="34" charset="-122"/>
                 <a:cs typeface="Calibri" pitchFamily="34" charset="-120"/>
               </a:rPr>
-              <a:t>teams: DSG · TSS · ASC · CTCG</a:t>
+              <a:t>invited teams</a:t>
             </a:r>
             <a:endParaRPr lang="en-US" sz="1250" dirty="0"/>
           </a:p>
@@ -3560,7 +3560,7 @@
         </p:nvSpPr>
         <p:spPr>
           <a:xfrm>
-            <a:off x="3154680" y="1828800"/>
+            <a:off x="3154680" y="1783080"/>
             <a:ext cx="2377440" cy="777240"/>
           </a:xfrm>
           <a:prstGeom prst="rect">
@@ -3599,7 +3599,7 @@
         </p:nvSpPr>
         <p:spPr>
           <a:xfrm>
-            <a:off x="3154680" y="2651760"/>
+            <a:off x="3154680" y="2606040"/>
             <a:ext cx="2377440" cy="502920"/>
           </a:xfrm>
           <a:prstGeom prst="rect">
@@ -3638,7 +3638,7 @@
         </p:nvSpPr>
         <p:spPr>
           <a:xfrm>
-            <a:off x="594360" y="3520440"/>
+            <a:off x="594360" y="3154680"/>
             <a:ext cx="2377440" cy="777240"/>
           </a:xfrm>
           <a:prstGeom prst="rect">
@@ -3677,7 +3677,7 @@
         </p:nvSpPr>
         <p:spPr>
           <a:xfrm>
-            <a:off x="594360" y="4343400"/>
+            <a:off x="594360" y="3977640"/>
             <a:ext cx="2377440" cy="502920"/>
           </a:xfrm>
           <a:prstGeom prst="rect">
@@ -3716,7 +3716,7 @@
         </p:nvSpPr>
         <p:spPr>
           <a:xfrm>
-            <a:off x="3154680" y="3520440"/>
+            <a:off x="3154680" y="3154680"/>
             <a:ext cx="2377440" cy="777240"/>
           </a:xfrm>
           <a:prstGeom prst="rect">
@@ -3755,7 +3755,7 @@
         </p:nvSpPr>
         <p:spPr>
           <a:xfrm>
-            <a:off x="3154680" y="4343400"/>
+            <a:off x="3154680" y="3977640"/>
             <a:ext cx="2377440" cy="502920"/>
           </a:xfrm>
           <a:prstGeom prst="rect">
@@ -3789,6 +3789,338 @@
       <p:sp>
         <p:nvSpPr>
           <p:cNvPr id="12" name="Shape 10"/>
+          <p:cNvSpPr/>
+          <p:nvPr/>
+        </p:nvSpPr>
+        <p:spPr>
+          <a:xfrm>
+            <a:off x="594360" y="4572000"/>
+            <a:ext cx="1261872" cy="603504"/>
+          </a:xfrm>
+          <a:prstGeom prst="roundRect">
+            <a:avLst>
+              <a:gd name="adj" fmla="val 15152"/>
+            </a:avLst>
+          </a:prstGeom>
+          <a:solidFill>
+            <a:srgbClr val="1B2E56"/>
+          </a:solidFill>
+          <a:ln w="12700">
+            <a:solidFill>
+              <a:srgbClr val="C8AA6E"/>
+            </a:solidFill>
+            <a:prstDash val="solid"/>
+          </a:ln>
+        </p:spPr>
+      </p:sp>
+      <p:sp>
+        <p:nvSpPr>
+          <p:cNvPr id="13" name="Text 11"/>
+          <p:cNvSpPr txBox="1"/>
+          <p:nvPr/>
+        </p:nvSpPr>
+        <p:spPr>
+          <a:xfrm>
+            <a:off x="594360" y="4572000"/>
+            <a:ext cx="1261872" cy="603504"/>
+          </a:xfrm>
+          <a:prstGeom prst="rect">
+            <a:avLst/>
+          </a:prstGeom>
+          <a:noFill/>
+          <a:ln/>
+        </p:spPr>
+        <p:txBody>
+          <a:bodyPr wrap="square" lIns="0" tIns="0" rIns="0" bIns="0" rtlCol="0" anchor="ctr"/>
+          <a:lstStyle/>
+          <a:p>
+            <a:pPr algn="ctr" indent="0" marL="0">
+              <a:buNone/>
+            </a:pPr>
+            <a:r>
+              <a:rPr lang="en-US" sz="1200" b="1" dirty="0">
+                <a:solidFill>
+                  <a:srgbClr val="F0C96A"/>
+                </a:solidFill>
+                <a:latin typeface="Calibri" pitchFamily="34" charset="0"/>
+                <a:ea typeface="Calibri" pitchFamily="34" charset="-122"/>
+                <a:cs typeface="Calibri" pitchFamily="34" charset="-120"/>
+              </a:rPr>
+              <a:t>DSG</a:t>
+            </a:r>
+            <a:endParaRPr lang="en-US" sz="1200" dirty="0"/>
+          </a:p>
+          <a:p>
+            <a:pPr algn="ctr" indent="0" marL="0">
+              <a:buNone/>
+            </a:pPr>
+            <a:r>
+              <a:rPr lang="en-US" sz="850" dirty="0">
+                <a:solidFill>
+                  <a:srgbClr val="F0E6D2"/>
+                </a:solidFill>
+                <a:latin typeface="Calibri" pitchFamily="34" charset="0"/>
+                <a:ea typeface="Calibri" pitchFamily="34" charset="-122"/>
+                <a:cs typeface="Calibri" pitchFamily="34" charset="-120"/>
+              </a:rPr>
+              <a:t>Disguised</a:t>
+            </a:r>
+            <a:endParaRPr lang="en-US" sz="1200" dirty="0"/>
+          </a:p>
+        </p:txBody>
+      </p:sp>
+      <p:sp>
+        <p:nvSpPr>
+          <p:cNvPr id="14" name="Shape 12"/>
+          <p:cNvSpPr/>
+          <p:nvPr/>
+        </p:nvSpPr>
+        <p:spPr>
+          <a:xfrm>
+            <a:off x="1947672" y="4572000"/>
+            <a:ext cx="1261872" cy="603504"/>
+          </a:xfrm>
+          <a:prstGeom prst="roundRect">
+            <a:avLst>
+              <a:gd name="adj" fmla="val 15152"/>
+            </a:avLst>
+          </a:prstGeom>
+          <a:solidFill>
+            <a:srgbClr val="1B2E56"/>
+          </a:solidFill>
+          <a:ln w="12700">
+            <a:solidFill>
+              <a:srgbClr val="C8AA6E"/>
+            </a:solidFill>
+            <a:prstDash val="solid"/>
+          </a:ln>
+        </p:spPr>
+      </p:sp>
+      <p:sp>
+        <p:nvSpPr>
+          <p:cNvPr id="15" name="Text 13"/>
+          <p:cNvSpPr txBox="1"/>
+          <p:nvPr/>
+        </p:nvSpPr>
+        <p:spPr>
+          <a:xfrm>
+            <a:off x="1947672" y="4572000"/>
+            <a:ext cx="1261872" cy="603504"/>
+          </a:xfrm>
+          <a:prstGeom prst="rect">
+            <a:avLst/>
+          </a:prstGeom>
+          <a:noFill/>
+          <a:ln/>
+        </p:spPr>
+        <p:txBody>
+          <a:bodyPr wrap="square" lIns="0" tIns="0" rIns="0" bIns="0" rtlCol="0" anchor="ctr"/>
+          <a:lstStyle/>
+          <a:p>
+            <a:pPr algn="ctr" indent="0" marL="0">
+              <a:buNone/>
+            </a:pPr>
+            <a:r>
+              <a:rPr lang="en-US" sz="1200" b="1" dirty="0">
+                <a:solidFill>
+                  <a:srgbClr val="F0C96A"/>
+                </a:solidFill>
+                <a:latin typeface="Calibri" pitchFamily="34" charset="0"/>
+                <a:ea typeface="Calibri" pitchFamily="34" charset="-122"/>
+                <a:cs typeface="Calibri" pitchFamily="34" charset="-120"/>
+              </a:rPr>
+              <a:t>TSS</a:t>
+            </a:r>
+            <a:endParaRPr lang="en-US" sz="1200" dirty="0"/>
+          </a:p>
+          <a:p>
+            <a:pPr algn="ctr" indent="0" marL="0">
+              <a:buNone/>
+            </a:pPr>
+            <a:r>
+              <a:rPr lang="en-US" sz="850" dirty="0">
+                <a:solidFill>
+                  <a:srgbClr val="F0E6D2"/>
+                </a:solidFill>
+                <a:latin typeface="Calibri" pitchFamily="34" charset="0"/>
+                <a:ea typeface="Calibri" pitchFamily="34" charset="-122"/>
+                <a:cs typeface="Calibri" pitchFamily="34" charset="-120"/>
+              </a:rPr>
+              <a:t>The Secret Sauce</a:t>
+            </a:r>
+            <a:endParaRPr lang="en-US" sz="1200" dirty="0"/>
+          </a:p>
+        </p:txBody>
+      </p:sp>
+      <p:sp>
+        <p:nvSpPr>
+          <p:cNvPr id="16" name="Shape 14"/>
+          <p:cNvSpPr/>
+          <p:nvPr/>
+        </p:nvSpPr>
+        <p:spPr>
+          <a:xfrm>
+            <a:off x="3300984" y="4572000"/>
+            <a:ext cx="1261872" cy="603504"/>
+          </a:xfrm>
+          <a:prstGeom prst="roundRect">
+            <a:avLst>
+              <a:gd name="adj" fmla="val 15152"/>
+            </a:avLst>
+          </a:prstGeom>
+          <a:solidFill>
+            <a:srgbClr val="1B2E56"/>
+          </a:solidFill>
+          <a:ln w="12700">
+            <a:solidFill>
+              <a:srgbClr val="C8AA6E"/>
+            </a:solidFill>
+            <a:prstDash val="solid"/>
+          </a:ln>
+        </p:spPr>
+      </p:sp>
+      <p:sp>
+        <p:nvSpPr>
+          <p:cNvPr id="17" name="Text 15"/>
+          <p:cNvSpPr txBox="1"/>
+          <p:nvPr/>
+        </p:nvSpPr>
+        <p:spPr>
+          <a:xfrm>
+            <a:off x="3300984" y="4572000"/>
+            <a:ext cx="1261872" cy="603504"/>
+          </a:xfrm>
+          <a:prstGeom prst="rect">
+            <a:avLst/>
+          </a:prstGeom>
+          <a:noFill/>
+          <a:ln/>
+        </p:spPr>
+        <p:txBody>
+          <a:bodyPr wrap="square" lIns="0" tIns="0" rIns="0" bIns="0" rtlCol="0" anchor="ctr"/>
+          <a:lstStyle/>
+          <a:p>
+            <a:pPr algn="ctr" indent="0" marL="0">
+              <a:buNone/>
+            </a:pPr>
+            <a:r>
+              <a:rPr lang="en-US" sz="1200" b="1" dirty="0">
+                <a:solidFill>
+                  <a:srgbClr val="F0C96A"/>
+                </a:solidFill>
+                <a:latin typeface="Calibri" pitchFamily="34" charset="0"/>
+                <a:ea typeface="Calibri" pitchFamily="34" charset="-122"/>
+                <a:cs typeface="Calibri" pitchFamily="34" charset="-120"/>
+              </a:rPr>
+              <a:t>ASC</a:t>
+            </a:r>
+            <a:endParaRPr lang="en-US" sz="1200" dirty="0"/>
+          </a:p>
+          <a:p>
+            <a:pPr algn="ctr" indent="0" marL="0">
+              <a:buNone/>
+            </a:pPr>
+            <a:r>
+              <a:rPr lang="en-US" sz="850" dirty="0">
+                <a:solidFill>
+                  <a:srgbClr val="F0E6D2"/>
+                </a:solidFill>
+                <a:latin typeface="Calibri" pitchFamily="34" charset="0"/>
+                <a:ea typeface="Calibri" pitchFamily="34" charset="-122"/>
+                <a:cs typeface="Calibri" pitchFamily="34" charset="-120"/>
+              </a:rPr>
+              <a:t>Ascension</a:t>
+            </a:r>
+            <a:endParaRPr lang="en-US" sz="1200" dirty="0"/>
+          </a:p>
+        </p:txBody>
+      </p:sp>
+      <p:sp>
+        <p:nvSpPr>
+          <p:cNvPr id="18" name="Shape 16"/>
+          <p:cNvSpPr/>
+          <p:nvPr/>
+        </p:nvSpPr>
+        <p:spPr>
+          <a:xfrm>
+            <a:off x="4654296" y="4572000"/>
+            <a:ext cx="1261872" cy="603504"/>
+          </a:xfrm>
+          <a:prstGeom prst="roundRect">
+            <a:avLst>
+              <a:gd name="adj" fmla="val 15152"/>
+            </a:avLst>
+          </a:prstGeom>
+          <a:solidFill>
+            <a:srgbClr val="1B2E56"/>
+          </a:solidFill>
+          <a:ln w="12700">
+            <a:solidFill>
+              <a:srgbClr val="C8AA6E"/>
+            </a:solidFill>
+            <a:prstDash val="solid"/>
+          </a:ln>
+        </p:spPr>
+      </p:sp>
+      <p:sp>
+        <p:nvSpPr>
+          <p:cNvPr id="19" name="Text 17"/>
+          <p:cNvSpPr txBox="1"/>
+          <p:nvPr/>
+        </p:nvSpPr>
+        <p:spPr>
+          <a:xfrm>
+            <a:off x="4654296" y="4572000"/>
+            <a:ext cx="1261872" cy="603504"/>
+          </a:xfrm>
+          <a:prstGeom prst="rect">
+            <a:avLst/>
+          </a:prstGeom>
+          <a:noFill/>
+          <a:ln/>
+        </p:spPr>
+        <p:txBody>
+          <a:bodyPr wrap="square" lIns="0" tIns="0" rIns="0" bIns="0" rtlCol="0" anchor="ctr"/>
+          <a:lstStyle/>
+          <a:p>
+            <a:pPr algn="ctr" indent="0" marL="0">
+              <a:buNone/>
+            </a:pPr>
+            <a:r>
+              <a:rPr lang="en-US" sz="1200" b="1" dirty="0">
+                <a:solidFill>
+                  <a:srgbClr val="F0C96A"/>
+                </a:solidFill>
+                <a:latin typeface="Calibri" pitchFamily="34" charset="0"/>
+                <a:ea typeface="Calibri" pitchFamily="34" charset="-122"/>
+                <a:cs typeface="Calibri" pitchFamily="34" charset="-120"/>
+              </a:rPr>
+              <a:t>CTCG</a:t>
+            </a:r>
+            <a:endParaRPr lang="en-US" sz="1200" dirty="0"/>
+          </a:p>
+          <a:p>
+            <a:pPr algn="ctr" indent="0" marL="0">
+              <a:buNone/>
+            </a:pPr>
+            <a:r>
+              <a:rPr lang="en-US" sz="850" dirty="0">
+                <a:solidFill>
+                  <a:srgbClr val="F0E6D2"/>
+                </a:solidFill>
+                <a:latin typeface="Calibri" pitchFamily="34" charset="0"/>
+                <a:ea typeface="Calibri" pitchFamily="34" charset="-122"/>
+                <a:cs typeface="Calibri" pitchFamily="34" charset="-120"/>
+              </a:rPr>
+              <a:t>Challenger TCG</a:t>
+            </a:r>
+            <a:endParaRPr lang="en-US" sz="1200" dirty="0"/>
+          </a:p>
+        </p:txBody>
+      </p:sp>
+      <p:sp>
+        <p:nvSpPr>
+          <p:cNvPr id="20" name="Shape 18"/>
           <p:cNvSpPr/>
           <p:nvPr/>
         </p:nvSpPr>
@@ -3822,7 +4154,7 @@
       </p:sp>
       <p:sp>
         <p:nvSpPr>
-          <p:cNvPr id="13" name="Text 11"/>
+          <p:cNvPr id="21" name="Text 19"/>
           <p:cNvSpPr txBox="1"/>
           <p:nvPr/>
         </p:nvSpPr>
@@ -3861,7 +4193,7 @@
       </p:sp>
       <p:pic>
         <p:nvPicPr>
-          <p:cNvPr id="14" name="Image 0" descr="preencoded.png">    </p:cNvPr>
+          <p:cNvPr id="22" name="Image 0" descr="preencoded.png">    </p:cNvPr>
           <p:cNvPicPr>
             <a:picLocks noChangeAspect="1"/>
           </p:cNvPicPr>
@@ -3885,7 +4217,7 @@
       </p:pic>
       <p:sp>
         <p:nvSpPr>
-          <p:cNvPr id="15" name="Text 12"/>
+          <p:cNvPr id="23" name="Text 20"/>
           <p:cNvSpPr txBox="1"/>
           <p:nvPr/>
         </p:nvSpPr>
@@ -3924,7 +4256,7 @@
       </p:sp>
       <p:pic>
         <p:nvPicPr>
-          <p:cNvPr id="16" name="Image 1" descr="preencoded.png">    </p:cNvPr>
+          <p:cNvPr id="24" name="Image 1" descr="preencoded.png">    </p:cNvPr>
           <p:cNvPicPr>
             <a:picLocks noChangeAspect="1"/>
           </p:cNvPicPr>
@@ -3948,7 +4280,7 @@
       </p:pic>
       <p:sp>
         <p:nvSpPr>
-          <p:cNvPr id="17" name="Text 13"/>
+          <p:cNvPr id="25" name="Text 21"/>
           <p:cNvSpPr txBox="1"/>
           <p:nvPr/>
         </p:nvSpPr>
@@ -3987,7 +4319,7 @@
       </p:sp>
       <p:pic>
         <p:nvPicPr>
-          <p:cNvPr id="18" name="Image 2" descr="preencoded.png">    </p:cNvPr>
+          <p:cNvPr id="26" name="Image 2" descr="preencoded.png">    </p:cNvPr>
           <p:cNvPicPr>
             <a:picLocks noChangeAspect="1"/>
           </p:cNvPicPr>
@@ -4011,7 +4343,7 @@
       </p:pic>
       <p:sp>
         <p:nvSpPr>
-          <p:cNvPr id="19" name="Text 14"/>
+          <p:cNvPr id="27" name="Text 22"/>
           <p:cNvSpPr txBox="1"/>
           <p:nvPr/>
         </p:nvSpPr>
@@ -4050,7 +4382,7 @@
       </p:sp>
       <p:pic>
         <p:nvPicPr>
-          <p:cNvPr id="20" name="Image 3" descr="preencoded.png">    </p:cNvPr>
+          <p:cNvPr id="28" name="Image 3" descr="preencoded.png">    </p:cNvPr>
           <p:cNvPicPr>
             <a:picLocks noChangeAspect="1"/>
           </p:cNvPicPr>
@@ -4074,7 +4406,7 @@
       </p:pic>
       <p:sp>
         <p:nvSpPr>
-          <p:cNvPr id="21" name="Text 15"/>
+          <p:cNvPr id="29" name="Text 23"/>
           <p:cNvSpPr txBox="1"/>
           <p:nvPr/>
         </p:nvSpPr>
@@ -4113,7 +4445,7 @@
       </p:sp>
       <p:pic>
         <p:nvPicPr>
-          <p:cNvPr id="22" name="Image 4" descr="preencoded.png">    </p:cNvPr>
+          <p:cNvPr id="30" name="Image 4" descr="preencoded.png">    </p:cNvPr>
           <p:cNvPicPr>
             <a:picLocks noChangeAspect="1"/>
           </p:cNvPicPr>
@@ -4137,7 +4469,7 @@
       </p:pic>
       <p:sp>
         <p:nvSpPr>
-          <p:cNvPr id="23" name="Text 16"/>
+          <p:cNvPr id="31" name="Text 24"/>
           <p:cNvSpPr txBox="1"/>
           <p:nvPr/>
         </p:nvSpPr>
@@ -4176,14 +4508,14 @@
       </p:sp>
       <p:sp>
         <p:nvSpPr>
-          <p:cNvPr id="24" name="Text 17"/>
-          <p:cNvSpPr txBox="1"/>
-          <p:nvPr/>
-        </p:nvSpPr>
-        <p:spPr>
-          <a:xfrm>
-            <a:off x="594360" y="5120640"/>
-            <a:ext cx="5303520" cy="868680"/>
+          <p:cNvPr id="32" name="Text 25"/>
+          <p:cNvSpPr txBox="1"/>
+          <p:nvPr/>
+        </p:nvSpPr>
+        <p:spPr>
+          <a:xfrm>
+            <a:off x="594360" y="5349240"/>
+            <a:ext cx="5303520" cy="777240"/>
           </a:xfrm>
           <a:prstGeom prst="rect">
             <a:avLst/>
@@ -4199,7 +4531,7 @@
               <a:buNone/>
             </a:pPr>
             <a:r>
-              <a:rPr lang="en-US" sz="1300" i="1" dirty="0">
+              <a:rPr lang="en-US" sz="1250" i="1" dirty="0">
                 <a:solidFill>
                   <a:srgbClr val="F0C96A"/>
                 </a:solidFill>
@@ -4209,13 +4541,13 @@
               </a:rPr>
               <a:t>Takeaway: the format works on a live stage, the teams showed up, and the VODs are on YouTube now. Next: do it with proper prize support and a Friday slot.</a:t>
             </a:r>
-            <a:endParaRPr lang="en-US" sz="1300" dirty="0"/>
-          </a:p>
-        </p:txBody>
-      </p:sp>
-      <p:sp>
-        <p:nvSpPr>
-          <p:cNvPr id="25" name="Text 18"/>
+            <a:endParaRPr lang="en-US" sz="1250" dirty="0"/>
+          </a:p>
+        </p:txBody>
+      </p:sp>
+      <p:sp>
+        <p:nvSpPr>
+          <p:cNvPr id="33" name="Text 26"/>
           <p:cNvSpPr txBox="1"/>
           <p:nvPr/>
         </p:nvSpPr>
@@ -4254,7 +4586,7 @@
       </p:sp>
       <p:sp>
         <p:nvSpPr>
-          <p:cNvPr id="26" name="Text 19"/>
+          <p:cNvPr id="34" name="Text 27"/>
           <p:cNvSpPr txBox="1"/>
           <p:nvPr/>
         </p:nvSpPr>
@@ -9799,7 +10131,7 @@
                 <a:ea typeface="Calibri" pitchFamily="34" charset="-122"/>
                 <a:cs typeface="Calibri" pitchFamily="34" charset="-120"/>
               </a:rPr>
-              <a:t>We invite the four teams and publish the schedule</a:t>
+              <a:t>Confirm the teams: Disguised, The Secret Sauce, Ascension, Challenger TCG</a:t>
             </a:r>
             <a:endParaRPr lang="en-US" sz="1250" dirty="0"/>
           </a:p>

</xml_diff>